<commit_message>
auto(analyze): portfolio PPT 2026-06-30T06:35:59Z
</commit_message>
<xml_diff>
--- a/reports/portfolio/2026-06-30.pptx
+++ b/reports/portfolio/2026-06-30.pptx
@@ -3192,7 +3192,7 @@
                   <a:srgbClr val="555555"/>
                 </a:solidFill>
               </a:rPr>
-              <a:t>분석 기간: 2026-06-29 00:00 ~ 2026-06-29 19:40</a:t>
+              <a:t>분석 기간: 2026-06-29 00:00 ~ 2026-06-30 15:25</a:t>
             </a:r>
           </a:p>
           <a:p>
@@ -3203,7 +3203,7 @@
                   <a:srgbClr val="555555"/>
                 </a:solidFill>
               </a:rPr>
-              <a:t>데이터: 총 237건 · 5분 해상도 · 전국 계통 기준</a:t>
+              <a:t>데이터: 총 474건 · 5분 해상도 · 전국 계통 기준</a:t>
             </a:r>
           </a:p>
           <a:p>
@@ -3214,7 +3214,7 @@
                   <a:srgbClr val="555555"/>
                 </a:solidFill>
               </a:rPr>
-              <a:t>생성일: 2026-06-30 10:54 KST</a:t>
+              <a:t>생성일: 2026-06-30 15:35 KST</a:t>
             </a:r>
           </a:p>
         </p:txBody>
@@ -4059,7 +4059,7 @@
                   <a:srgbClr val="555555"/>
                 </a:solidFill>
               </a:rPr>
-              <a:t>•  총 237건 · 20시간 분량 5분 해상도 수집·분석</a:t>
+              <a:t>•  총 474건 · 39시간 분량 5분 해상도 수집·분석</a:t>
             </a:r>
           </a:p>
           <a:p>
@@ -4074,7 +4074,7 @@
                   <a:srgbClr val="555555"/>
                 </a:solidFill>
               </a:rPr>
-              <a:t>•  다층 이상탐지 결과: EWMA:0건 · CUSUM:18건 · IForest:5건 · 잔차:0건 · LSTM-AE:스킵</a:t>
+              <a:t>•  다층 이상탐지 결과: EWMA:1건 · CUSUM:31건 · IForest:0건 · 잔차:0건 · LSTM-AE:스킵</a:t>
             </a:r>
           </a:p>
           <a:p>

</xml_diff>

<commit_message>
auto(analyze): portfolio PPT 2026-06-30T10:20:48Z
</commit_message>
<xml_diff>
--- a/reports/portfolio/2026-06-30.pptx
+++ b/reports/portfolio/2026-06-30.pptx
@@ -3192,7 +3192,7 @@
                   <a:srgbClr val="555555"/>
                 </a:solidFill>
               </a:rPr>
-              <a:t>분석 기간: 2026-06-29 00:00 ~ 2026-06-30 15:25</a:t>
+              <a:t>분석 기간: 2026-06-29 00:00 ~ 2026-06-30 18:45</a:t>
             </a:r>
           </a:p>
           <a:p>
@@ -3203,7 +3203,7 @@
                   <a:srgbClr val="555555"/>
                 </a:solidFill>
               </a:rPr>
-              <a:t>데이터: 총 474건 · 5분 해상도 · 전국 계통 기준</a:t>
+              <a:t>데이터: 총 514건 · 5분 해상도 · 전국 계통 기준</a:t>
             </a:r>
           </a:p>
           <a:p>
@@ -3214,7 +3214,7 @@
                   <a:srgbClr val="555555"/>
                 </a:solidFill>
               </a:rPr>
-              <a:t>생성일: 2026-06-30 15:35 KST</a:t>
+              <a:t>생성일: 2026-06-30 19:20 KST</a:t>
             </a:r>
           </a:p>
         </p:txBody>
@@ -4059,7 +4059,7 @@
                   <a:srgbClr val="555555"/>
                 </a:solidFill>
               </a:rPr>
-              <a:t>•  총 474건 · 39시간 분량 5분 해상도 수집·분석</a:t>
+              <a:t>•  총 514건 · 43시간 분량 5분 해상도 수집·분석</a:t>
             </a:r>
           </a:p>
           <a:p>
@@ -4074,7 +4074,7 @@
                   <a:srgbClr val="555555"/>
                 </a:solidFill>
               </a:rPr>
-              <a:t>•  다층 이상탐지 결과: EWMA:1건 · CUSUM:31건 · IForest:0건 · 잔차:0건 · LSTM-AE:스킵</a:t>
+              <a:t>•  다층 이상탐지 결과: EWMA:2건 · CUSUM:34건 · IForest:0건 · 잔차:0건 · LSTM-AE:스킵</a:t>
             </a:r>
           </a:p>
           <a:p>
@@ -4089,7 +4089,7 @@
                   <a:srgbClr val="555555"/>
                 </a:solidFill>
               </a:rPr>
-              <a:t>•  최대 부하: 78,641 MW (06-29 18:30)</a:t>
+              <a:t>•  최대 부하: 79,027 MW (06-30 18:40)</a:t>
             </a:r>
           </a:p>
           <a:p>
@@ -4104,7 +4104,7 @@
                   <a:srgbClr val="555555"/>
                 </a:solidFill>
               </a:rPr>
-              <a:t>•  최저 예비율: 23.6% (06-29 18:55) — 위험 시점</a:t>
+              <a:t>•  최저 예비율: 7.1% (06-30 16:40) — 위험 시점</a:t>
             </a:r>
           </a:p>
           <a:p>

</xml_diff>

<commit_message>
auto(analyze): portfolio PPT 2026-06-30T12:27:57Z
</commit_message>
<xml_diff>
--- a/reports/portfolio/2026-06-30.pptx
+++ b/reports/portfolio/2026-06-30.pptx
@@ -3192,7 +3192,7 @@
                   <a:srgbClr val="555555"/>
                 </a:solidFill>
               </a:rPr>
-              <a:t>분석 기간: 2026-06-29 00:00 ~ 2026-06-30 18:45</a:t>
+              <a:t>분석 기간: 2026-06-29 00:00 ~ 2026-06-30 20:45</a:t>
             </a:r>
           </a:p>
           <a:p>
@@ -3203,7 +3203,7 @@
                   <a:srgbClr val="555555"/>
                 </a:solidFill>
               </a:rPr>
-              <a:t>데이터: 총 514건 · 5분 해상도 · 전국 계통 기준</a:t>
+              <a:t>데이터: 총 538건 · 5분 해상도 · 전국 계통 기준</a:t>
             </a:r>
           </a:p>
           <a:p>
@@ -3214,7 +3214,7 @@
                   <a:srgbClr val="555555"/>
                 </a:solidFill>
               </a:rPr>
-              <a:t>생성일: 2026-06-30 19:20 KST</a:t>
+              <a:t>생성일: 2026-06-30 21:27 KST</a:t>
             </a:r>
           </a:p>
         </p:txBody>
@@ -4059,7 +4059,7 @@
                   <a:srgbClr val="555555"/>
                 </a:solidFill>
               </a:rPr>
-              <a:t>•  총 514건 · 43시간 분량 5분 해상도 수집·분석</a:t>
+              <a:t>•  총 538건 · 45시간 분량 5분 해상도 수집·분석</a:t>
             </a:r>
           </a:p>
           <a:p>
@@ -4074,7 +4074,7 @@
                   <a:srgbClr val="555555"/>
                 </a:solidFill>
               </a:rPr>
-              <a:t>•  다층 이상탐지 결과: EWMA:2건 · CUSUM:34건 · IForest:0건 · 잔차:0건 · LSTM-AE:스킵</a:t>
+              <a:t>•  다층 이상탐지 결과: EWMA:2건 · CUSUM:37건 · IForest:0건 · 잔차:0건 · LSTM-AE:스킵</a:t>
             </a:r>
           </a:p>
           <a:p>

</xml_diff>